<commit_message>
Corregir mapeo exacto de figuras e imagenes del informe en el PPT
</commit_message>
<xml_diff>
--- a/Exposicion_SIRVS_Ximasak_T2.pptx
+++ b/Exposicion_SIRVS_Ximasak_T2.pptx
@@ -5472,9 +5472,44 @@
           </a:p>
         </p:txBody>
       </p:sp>
+      <p:sp>
+        <p:nvSpPr>
+          <p:cNvPr id="8" name="TextBox 7"/>
+          <p:cNvSpPr txBox="1"/>
+          <p:nvPr/>
+        </p:nvSpPr>
+        <p:spPr>
+          <a:xfrm>
+            <a:off x="6217920" y="1737360"/>
+            <a:ext cx="5029200" cy="365760"/>
+          </a:xfrm>
+          <a:prstGeom prst="rect">
+            <a:avLst/>
+          </a:prstGeom>
+          <a:noFill/>
+        </p:spPr>
+        <p:txBody>
+          <a:bodyPr wrap="none">
+            <a:spAutoFit/>
+          </a:bodyPr>
+          <a:lstStyle/>
+          <a:p>
+            <a:pPr>
+              <a:defRPr sz="1100" b="1">
+                <a:solidFill>
+                  <a:srgbClr val="5B21B6"/>
+                </a:solidFill>
+              </a:defRPr>
+            </a:pPr>
+            <a:r>
+              <a:t>FIGURA 8: DASHBOARD ADMINISTRATIVO Y KPIS</a:t>
+            </a:r>
+          </a:p>
+        </p:txBody>
+      </p:sp>
       <p:pic>
         <p:nvPicPr>
-          <p:cNvPr id="8" name="Picture 7" descr="image8.png"/>
+          <p:cNvPr id="9" name="Picture 8" descr="image7.png"/>
           <p:cNvPicPr>
             <a:picLocks noChangeAspect="1"/>
           </p:cNvPicPr>
@@ -5488,8 +5523,8 @@
         </p:blipFill>
         <p:spPr>
           <a:xfrm>
-            <a:off x="6217920" y="1920240"/>
-            <a:ext cx="5029200" cy="3931920"/>
+            <a:off x="6217920" y="2194560"/>
+            <a:ext cx="5029200" cy="3657600"/>
           </a:xfrm>
           <a:prstGeom prst="rect">
             <a:avLst/>
@@ -6236,7 +6271,7 @@
           </a:p>
           <a:p>
             <a:pPr>
-              <a:defRPr sz="1100">
+              <a:defRPr sz="1050">
                 <a:solidFill>
                   <a:srgbClr val="334155"/>
                 </a:solidFill>
@@ -6249,7 +6284,7 @@
           <a:p>
             <a:br/>
             <a:pPr>
-              <a:defRPr sz="1200" b="1">
+              <a:defRPr sz="1150" b="1">
                 <a:solidFill>
                   <a:srgbClr val="1E1B4B"/>
                 </a:solidFill>
@@ -6269,12 +6304,12 @@
               <a:t>• Demoras en Mostrador (PE-01):</a:t>
             </a:r>
             <a:r>
-              <a:rPr sz="1000">
+              <a:rPr sz="950">
                 <a:solidFill>
                   <a:srgbClr val="334155"/>
                 </a:solidFill>
               </a:rPr>
-              <a:t> Registro manual y lento de clientes; no existía búsqueda ágil por DNI/RUC.</a:t>
+              <a:t> Registro manual y lento de clientes; ausencia de búsqueda ágil por DNI/RUC.</a:t>
             </a:r>
           </a:p>
           <a:p>
@@ -6287,7 +6322,7 @@
               <a:t>• Quiebres de Stock (PE-02):</a:t>
             </a:r>
             <a:r>
-              <a:rPr sz="1000">
+              <a:rPr sz="950">
                 <a:solidFill>
                   <a:srgbClr val="334155"/>
                 </a:solidFill>
@@ -6305,7 +6340,7 @@
               <a:t>• Opacidad y Falta de Trazabilidad (PE-03):</a:t>
             </a:r>
             <a:r>
-              <a:rPr sz="1000">
+              <a:rPr sz="950">
                 <a:solidFill>
                   <a:srgbClr val="334155"/>
                 </a:solidFill>
@@ -6383,21 +6418,21 @@
           <a:lstStyle/>
           <a:p>
             <a:pPr>
-              <a:defRPr sz="1200" b="1">
+              <a:defRPr sz="1100" b="1">
                 <a:solidFill>
                   <a:srgbClr val="5B21B6"/>
                 </a:solidFill>
               </a:defRPr>
             </a:pPr>
             <a:r>
-              <a:t>ESTRUCTURA ORGANIZACIONAL Y ROLES (FIGURA 1)</a:t>
+              <a:t>FIGURA 1: ESTRUCTURA ORGANIZACIONAL Y ROLES</a:t>
             </a:r>
           </a:p>
         </p:txBody>
       </p:sp>
       <p:pic>
         <p:nvPicPr>
-          <p:cNvPr id="9" name="Picture 8" descr="image1.png"/>
+          <p:cNvPr id="9" name="Picture 8" descr="image2.jpg"/>
           <p:cNvPicPr>
             <a:picLocks noChangeAspect="1"/>
           </p:cNvPicPr>
@@ -6412,7 +6447,7 @@
         <p:spPr>
           <a:xfrm>
             <a:off x="6309360" y="2194560"/>
-            <a:ext cx="4937760" cy="3566160"/>
+            <a:ext cx="4937760" cy="3474720"/>
           </a:xfrm>
           <a:prstGeom prst="rect">
             <a:avLst/>
@@ -6521,7 +6556,7 @@
               </a:defRPr>
             </a:pPr>
             <a:r>
-              <a:t>Objetivos del Proyecto y Alcance Funcional</a:t>
+              <a:t>Objetivos del Proyecto y Solución Integral SIRVS</a:t>
             </a:r>
           </a:p>
         </p:txBody>
@@ -6578,99 +6613,7 @@
         <p:spPr>
           <a:xfrm>
             <a:off x="731520" y="1645920"/>
-            <a:ext cx="10698480" cy="1188720"/>
-          </a:xfrm>
-          <a:prstGeom prst="roundRect">
-            <a:avLst/>
-          </a:prstGeom>
-          <a:solidFill>
-            <a:srgbClr val="4A154B"/>
-          </a:solidFill>
-          <a:ln w="12700">
-            <a:solidFill>
-              <a:srgbClr val="5B21B6"/>
-            </a:solidFill>
-          </a:ln>
-        </p:spPr>
-        <p:style>
-          <a:lnRef idx="1">
-            <a:schemeClr val="accent1"/>
-          </a:lnRef>
-          <a:fillRef idx="3">
-            <a:schemeClr val="accent1"/>
-          </a:fillRef>
-          <a:effectRef idx="2">
-            <a:schemeClr val="accent1"/>
-          </a:effectRef>
-          <a:fontRef idx="minor">
-            <a:schemeClr val="lt1"/>
-          </a:fontRef>
-        </p:style>
-        <p:txBody>
-          <a:bodyPr rtlCol="0" anchor="ctr"/>
-          <a:lstStyle/>
-          <a:p>
-            <a:pPr algn="ctr"/>
-          </a:p>
-        </p:txBody>
-      </p:sp>
-      <p:sp>
-        <p:nvSpPr>
-          <p:cNvPr id="6" name="TextBox 5"/>
-          <p:cNvSpPr txBox="1"/>
-          <p:nvPr/>
-        </p:nvSpPr>
-        <p:spPr>
-          <a:xfrm>
-            <a:off x="914400" y="1737360"/>
-            <a:ext cx="10332720" cy="1005840"/>
-          </a:xfrm>
-          <a:prstGeom prst="rect">
-            <a:avLst/>
-          </a:prstGeom>
-          <a:noFill/>
-        </p:spPr>
-        <p:txBody>
-          <a:bodyPr wrap="square">
-            <a:spAutoFit/>
-          </a:bodyPr>
-          <a:lstStyle/>
-          <a:p>
-            <a:pPr>
-              <a:defRPr sz="1200" b="1">
-                <a:solidFill>
-                  <a:srgbClr val="DDD6FE"/>
-                </a:solidFill>
-              </a:defRPr>
-            </a:pPr>
-            <a:r>
-              <a:t>OBJETIVO GENERAL DEL PROYECTO</a:t>
-            </a:r>
-          </a:p>
-          <a:p>
-            <a:pPr>
-              <a:defRPr sz="1200">
-                <a:solidFill>
-                  <a:srgbClr val="FFFFFF"/>
-                </a:solidFill>
-              </a:defRPr>
-            </a:pPr>
-            <a:r>
-              <a:t>Desarrollar e implementar el Sistema Integrado de Reservas de Ventas y Servicio Técnico (SIRVS) para optimizar de manera integral los procesos operativos, comerciales y de soporte técnico de la empresa Ximasak EIRL.</a:t>
-            </a:r>
-          </a:p>
-        </p:txBody>
-      </p:sp>
-      <p:sp>
-        <p:nvSpPr>
-          <p:cNvPr id="7" name="Rounded Rectangle 6"/>
-          <p:cNvSpPr/>
-          <p:nvPr/>
-        </p:nvSpPr>
-        <p:spPr>
-          <a:xfrm>
-            <a:off x="731520" y="3108960"/>
-            <a:ext cx="3383280" cy="3108960"/>
+            <a:ext cx="5029200" cy="4572000"/>
           </a:xfrm>
           <a:prstGeom prst="roundRect">
             <a:avLst/>
@@ -6708,14 +6651,14 @@
       </p:sp>
       <p:sp>
         <p:nvSpPr>
-          <p:cNvPr id="8" name="TextBox 7"/>
+          <p:cNvPr id="6" name="TextBox 5"/>
           <p:cNvSpPr txBox="1"/>
           <p:nvPr/>
         </p:nvSpPr>
         <p:spPr>
           <a:xfrm>
-            <a:off x="914400" y="3291840"/>
-            <a:ext cx="3017520" cy="2743200"/>
+            <a:off x="914400" y="1737360"/>
+            <a:ext cx="4663440" cy="4389120"/>
           </a:xfrm>
           <a:prstGeom prst="rect">
             <a:avLst/>
@@ -6729,63 +6672,113 @@
           <a:lstStyle/>
           <a:p>
             <a:pPr>
-              <a:defRPr sz="1300" b="1">
+              <a:defRPr sz="1200" b="1">
                 <a:solidFill>
                   <a:srgbClr val="5B21B6"/>
                 </a:solidFill>
               </a:defRPr>
             </a:pPr>
             <a:r>
-              <a:t>OE-01: Módulo Ventas &amp; POS</a:t>
+              <a:t>OBJETIVO GENERAL DEL PROYECTO</a:t>
             </a:r>
           </a:p>
           <a:p>
             <a:pPr>
-              <a:defRPr sz="1100">
+              <a:defRPr sz="1050">
                 <a:solidFill>
                   <a:srgbClr val="334155"/>
                 </a:solidFill>
               </a:defRPr>
             </a:pPr>
             <a:r>
-              <a:t>Automatización de ventas en mostrador con cálculo de IGV (18%), carrito de compras dinámico y generación de boletas/facturas digitales en PDF.</a:t>
+              <a:t>Desarrollar e implementar el Sistema Integrado de Reservas de Ventas y Servicio Técnico (SIRVS) para optimizar los procesos comerciales y de taller en Ximasak EIRL.</a:t>
             </a:r>
           </a:p>
           <a:p>
             <a:br/>
             <a:pPr>
-              <a:defRPr sz="1000" b="1">
+              <a:defRPr sz="1150" b="1">
                 <a:solidFill>
                   <a:srgbClr val="1E1B4B"/>
                 </a:solidFill>
               </a:defRPr>
             </a:pPr>
             <a:r>
-              <a:t>Historias Asociadas:</a:t>
-            </a:r>
-            <a:br/>
-            <a:r>
-              <a:t>HU-04, HU-05</a:t>
-            </a:r>
-          </a:p>
-        </p:txBody>
-      </p:sp>
-      <p:sp>
-        <p:nvSpPr>
-          <p:cNvPr id="9" name="Rounded Rectangle 8"/>
+              <a:t>🎯 Objetivos Específicos:</a:t>
+            </a:r>
+          </a:p>
+          <a:p>
+            <a:r>
+              <a:rPr b="1" sz="1000">
+                <a:solidFill>
+                  <a:srgbClr val="5B21B6"/>
+                </a:solidFill>
+              </a:rPr>
+              <a:t>✔ OE-01: Ventas y POS:</a:t>
+            </a:r>
+            <a:r>
+              <a:rPr sz="950">
+                <a:solidFill>
+                  <a:srgbClr val="334155"/>
+                </a:solidFill>
+              </a:rPr>
+              <a:t> Automatizar cobro con cálculo de IGV (18%), carrito y emisión de boletas/facturas en PDF.</a:t>
+            </a:r>
+          </a:p>
+          <a:p>
+            <a:r>
+              <a:rPr b="1" sz="1000">
+                <a:solidFill>
+                  <a:srgbClr val="5B21B6"/>
+                </a:solidFill>
+              </a:rPr>
+              <a:t>✔ OE-02: Soporte y Citas:</a:t>
+            </a:r>
+            <a:r>
+              <a:rPr sz="950">
+                <a:solidFill>
+                  <a:srgbClr val="334155"/>
+                </a:solidFill>
+              </a:rPr>
+              <a:t> Agendar citas con calendario interactivo y trazabilidad completa del equipo ingresado.</a:t>
+            </a:r>
+          </a:p>
+          <a:p>
+            <a:r>
+              <a:rPr b="1" sz="1000">
+                <a:solidFill>
+                  <a:srgbClr val="5B21B6"/>
+                </a:solidFill>
+              </a:rPr>
+              <a:t>✔ OE-03: Control de Stock:</a:t>
+            </a:r>
+            <a:r>
+              <a:rPr sz="950">
+                <a:solidFill>
+                  <a:srgbClr val="334155"/>
+                </a:solidFill>
+              </a:rPr>
+              <a:t> Descuento transaccional en tiempo real de repuestos y alertas visuales de stock crítico.</a:t>
+            </a:r>
+          </a:p>
+        </p:txBody>
+      </p:sp>
+      <p:sp>
+        <p:nvSpPr>
+          <p:cNvPr id="7" name="Rounded Rectangle 6"/>
           <p:cNvSpPr/>
           <p:nvPr/>
         </p:nvSpPr>
         <p:spPr>
           <a:xfrm>
-            <a:off x="4389120" y="3108960"/>
-            <a:ext cx="3383280" cy="3108960"/>
+            <a:off x="6035040" y="1645920"/>
+            <a:ext cx="5394960" cy="4572000"/>
           </a:xfrm>
           <a:prstGeom prst="roundRect">
             <a:avLst/>
           </a:prstGeom>
           <a:solidFill>
-            <a:srgbClr val="F5F3FF"/>
+            <a:srgbClr val="FFFFFF"/>
           </a:solidFill>
           <a:ln w="12700">
             <a:solidFill>
@@ -6817,14 +6810,14 @@
       </p:sp>
       <p:sp>
         <p:nvSpPr>
-          <p:cNvPr id="10" name="TextBox 9"/>
+          <p:cNvPr id="8" name="TextBox 7"/>
           <p:cNvSpPr txBox="1"/>
           <p:nvPr/>
         </p:nvSpPr>
         <p:spPr>
           <a:xfrm>
-            <a:off x="4572000" y="3291840"/>
-            <a:ext cx="3017520" cy="2743200"/>
+            <a:off x="6217920" y="1737360"/>
+            <a:ext cx="5029200" cy="365760"/>
           </a:xfrm>
           <a:prstGeom prst="rect">
             <a:avLst/>
@@ -6832,162 +6825,48 @@
           <a:noFill/>
         </p:spPr>
         <p:txBody>
-          <a:bodyPr wrap="square">
+          <a:bodyPr wrap="none">
             <a:spAutoFit/>
           </a:bodyPr>
           <a:lstStyle/>
           <a:p>
             <a:pPr>
-              <a:defRPr sz="1300" b="1">
+              <a:defRPr sz="1100" b="1">
                 <a:solidFill>
                   <a:srgbClr val="5B21B6"/>
                 </a:solidFill>
               </a:defRPr>
             </a:pPr>
             <a:r>
-              <a:t>OE-02: Soporte &amp; Citas</a:t>
-            </a:r>
-          </a:p>
-          <a:p>
-            <a:pPr>
-              <a:defRPr sz="1100">
-                <a:solidFill>
-                  <a:srgbClr val="334155"/>
-                </a:solidFill>
-              </a:defRPr>
-            </a:pPr>
-            <a:r>
-              <a:t>Agendamiento con calendario mensual dinámico, atención de tickets por técnicos y alertas automáticas por correo al finalizar reparaciones.</a:t>
-            </a:r>
-          </a:p>
-          <a:p>
-            <a:br/>
-            <a:pPr>
-              <a:defRPr sz="1000" b="1">
-                <a:solidFill>
-                  <a:srgbClr val="1E1B4B"/>
-                </a:solidFill>
-              </a:defRPr>
-            </a:pPr>
-            <a:r>
-              <a:t>Historias Asociadas:</a:t>
-            </a:r>
-            <a:br/>
-            <a:r>
-              <a:t>HU-06, HU-08, HU-11</a:t>
-            </a:r>
-          </a:p>
-        </p:txBody>
-      </p:sp>
-      <p:sp>
-        <p:nvSpPr>
-          <p:cNvPr id="11" name="Rounded Rectangle 10"/>
-          <p:cNvSpPr/>
-          <p:nvPr/>
-        </p:nvSpPr>
-        <p:spPr>
-          <a:xfrm>
-            <a:off x="8046720" y="3108960"/>
-            <a:ext cx="3383280" cy="3108960"/>
-          </a:xfrm>
-          <a:prstGeom prst="roundRect">
-            <a:avLst/>
-          </a:prstGeom>
-          <a:solidFill>
-            <a:srgbClr val="F5F3FF"/>
-          </a:solidFill>
-          <a:ln w="12700">
-            <a:solidFill>
-              <a:srgbClr val="DDD6FE"/>
-            </a:solidFill>
-          </a:ln>
-        </p:spPr>
-        <p:style>
-          <a:lnRef idx="1">
-            <a:schemeClr val="accent1"/>
-          </a:lnRef>
-          <a:fillRef idx="3">
-            <a:schemeClr val="accent1"/>
-          </a:fillRef>
-          <a:effectRef idx="2">
-            <a:schemeClr val="accent1"/>
-          </a:effectRef>
-          <a:fontRef idx="minor">
-            <a:schemeClr val="lt1"/>
-          </a:fontRef>
-        </p:style>
-        <p:txBody>
-          <a:bodyPr rtlCol="0" anchor="ctr"/>
-          <a:lstStyle/>
-          <a:p>
-            <a:pPr algn="ctr"/>
-          </a:p>
-        </p:txBody>
-      </p:sp>
-      <p:sp>
-        <p:nvSpPr>
-          <p:cNvPr id="12" name="TextBox 11"/>
-          <p:cNvSpPr txBox="1"/>
-          <p:nvPr/>
-        </p:nvSpPr>
-        <p:spPr>
-          <a:xfrm>
-            <a:off x="8229600" y="3291840"/>
-            <a:ext cx="3017520" cy="2743200"/>
+              <a:t>FIGURA 2: PÁGINA PRINCIPAL SIRVS Y SERVICIOS</a:t>
+            </a:r>
+          </a:p>
+        </p:txBody>
+      </p:sp>
+      <p:pic>
+        <p:nvPicPr>
+          <p:cNvPr id="9" name="Picture 8" descr="image6.png"/>
+          <p:cNvPicPr>
+            <a:picLocks noChangeAspect="1"/>
+          </p:cNvPicPr>
+          <p:nvPr/>
+        </p:nvPicPr>
+        <p:blipFill>
+          <a:blip r:embed="rId2"/>
+          <a:stretch>
+            <a:fillRect/>
+          </a:stretch>
+        </p:blipFill>
+        <p:spPr>
+          <a:xfrm>
+            <a:off x="6217920" y="2194560"/>
+            <a:ext cx="5029200" cy="3474720"/>
           </a:xfrm>
           <a:prstGeom prst="rect">
             <a:avLst/>
           </a:prstGeom>
-          <a:noFill/>
-        </p:spPr>
-        <p:txBody>
-          <a:bodyPr wrap="square">
-            <a:spAutoFit/>
-          </a:bodyPr>
-          <a:lstStyle/>
-          <a:p>
-            <a:pPr>
-              <a:defRPr sz="1300" b="1">
-                <a:solidFill>
-                  <a:srgbClr val="5B21B6"/>
-                </a:solidFill>
-              </a:defRPr>
-            </a:pPr>
-            <a:r>
-              <a:t>OE-03: Control de Inventario</a:t>
-            </a:r>
-          </a:p>
-          <a:p>
-            <a:pPr>
-              <a:defRPr sz="1100">
-                <a:solidFill>
-                  <a:srgbClr val="334155"/>
-                </a:solidFill>
-              </a:defRPr>
-            </a:pPr>
-            <a:r>
-              <a:t>Descuento transaccional inmediato de stock por ventas y mantenimientos, con alertas visuales de inventario crítico en el dashboard.</a:t>
-            </a:r>
-          </a:p>
-          <a:p>
-            <a:br/>
-            <a:pPr>
-              <a:defRPr sz="1000" b="1">
-                <a:solidFill>
-                  <a:srgbClr val="1E1B4B"/>
-                </a:solidFill>
-              </a:defRPr>
-            </a:pPr>
-            <a:r>
-              <a:t>Historias Asociadas:</a:t>
-            </a:r>
-            <a:br/>
-            <a:r>
-              <a:t>HU-09, HU-10, HU-12</a:t>
-            </a:r>
-          </a:p>
-        </p:txBody>
-      </p:sp>
+        </p:spPr>
+      </p:pic>
     </p:spTree>
   </p:cSld>
   <p:clrMapOvr>
@@ -8459,9 +8338,44 @@
           </a:p>
         </p:txBody>
       </p:sp>
+      <p:sp>
+        <p:nvSpPr>
+          <p:cNvPr id="8" name="TextBox 7"/>
+          <p:cNvSpPr txBox="1"/>
+          <p:nvPr/>
+        </p:nvSpPr>
+        <p:spPr>
+          <a:xfrm>
+            <a:off x="5852160" y="1691640"/>
+            <a:ext cx="5486400" cy="274320"/>
+          </a:xfrm>
+          <a:prstGeom prst="rect">
+            <a:avLst/>
+          </a:prstGeom>
+          <a:noFill/>
+        </p:spPr>
+        <p:txBody>
+          <a:bodyPr wrap="none">
+            <a:spAutoFit/>
+          </a:bodyPr>
+          <a:lstStyle/>
+          <a:p>
+            <a:pPr>
+              <a:defRPr sz="950" b="1">
+                <a:solidFill>
+                  <a:srgbClr val="5B21B6"/>
+                </a:solidFill>
+              </a:defRPr>
+            </a:pPr>
+            <a:r>
+              <a:t>FIGURA 3: MODAL DE ACCESO Y REGISTRO</a:t>
+            </a:r>
+          </a:p>
+        </p:txBody>
+      </p:sp>
       <p:pic>
         <p:nvPicPr>
-          <p:cNvPr id="8" name="Picture 7" descr="image3.png"/>
+          <p:cNvPr id="9" name="Picture 8" descr="image3.png"/>
           <p:cNvPicPr>
             <a:picLocks noChangeAspect="1"/>
           </p:cNvPicPr>
@@ -8475,8 +8389,8 @@
         </p:blipFill>
         <p:spPr>
           <a:xfrm>
-            <a:off x="5943600" y="1737360"/>
-            <a:ext cx="5303520" cy="2011680"/>
+            <a:off x="5943600" y="1965960"/>
+            <a:ext cx="5303520" cy="1783080"/>
           </a:xfrm>
           <a:prstGeom prst="rect">
             <a:avLst/>
@@ -8485,7 +8399,7 @@
       </p:pic>
       <p:sp>
         <p:nvSpPr>
-          <p:cNvPr id="9" name="Rounded Rectangle 8"/>
+          <p:cNvPr id="10" name="Rounded Rectangle 9"/>
           <p:cNvSpPr/>
           <p:nvPr/>
         </p:nvSpPr>
@@ -8528,9 +8442,44 @@
           </a:p>
         </p:txBody>
       </p:sp>
+      <p:sp>
+        <p:nvSpPr>
+          <p:cNvPr id="11" name="TextBox 10"/>
+          <p:cNvSpPr txBox="1"/>
+          <p:nvPr/>
+        </p:nvSpPr>
+        <p:spPr>
+          <a:xfrm>
+            <a:off x="5852160" y="4069080"/>
+            <a:ext cx="5486400" cy="274320"/>
+          </a:xfrm>
+          <a:prstGeom prst="rect">
+            <a:avLst/>
+          </a:prstGeom>
+          <a:noFill/>
+        </p:spPr>
+        <p:txBody>
+          <a:bodyPr wrap="none">
+            <a:spAutoFit/>
+          </a:bodyPr>
+          <a:lstStyle/>
+          <a:p>
+            <a:pPr>
+              <a:defRPr sz="950" b="1">
+                <a:solidFill>
+                  <a:srgbClr val="5B21B6"/>
+                </a:solidFill>
+              </a:defRPr>
+            </a:pPr>
+            <a:r>
+              <a:t>FIGURA 4: INGRESO DE CREDENCIALES DE ADMINISTRADOR</a:t>
+            </a:r>
+          </a:p>
+        </p:txBody>
+      </p:sp>
       <p:pic>
         <p:nvPicPr>
-          <p:cNvPr id="10" name="Picture 9" descr="image4.png"/>
+          <p:cNvPr id="12" name="Picture 11" descr="image4.png"/>
           <p:cNvPicPr>
             <a:picLocks noChangeAspect="1"/>
           </p:cNvPicPr>
@@ -8544,8 +8493,8 @@
         </p:blipFill>
         <p:spPr>
           <a:xfrm>
-            <a:off x="5943600" y="4114800"/>
-            <a:ext cx="5303520" cy="2011680"/>
+            <a:off x="5943600" y="4343400"/>
+            <a:ext cx="5303520" cy="1783080"/>
           </a:xfrm>
           <a:prstGeom prst="rect">
             <a:avLst/>
@@ -8907,9 +8856,44 @@
           </a:p>
         </p:txBody>
       </p:sp>
+      <p:sp>
+        <p:nvSpPr>
+          <p:cNvPr id="8" name="TextBox 7"/>
+          <p:cNvSpPr txBox="1"/>
+          <p:nvPr/>
+        </p:nvSpPr>
+        <p:spPr>
+          <a:xfrm>
+            <a:off x="6217920" y="1737360"/>
+            <a:ext cx="5029200" cy="365760"/>
+          </a:xfrm>
+          <a:prstGeom prst="rect">
+            <a:avLst/>
+          </a:prstGeom>
+          <a:noFill/>
+        </p:spPr>
+        <p:txBody>
+          <a:bodyPr wrap="none">
+            <a:spAutoFit/>
+          </a:bodyPr>
+          <a:lstStyle/>
+          <a:p>
+            <a:pPr>
+              <a:defRPr sz="1100" b="1">
+                <a:solidFill>
+                  <a:srgbClr val="5B21B6"/>
+                </a:solidFill>
+              </a:defRPr>
+            </a:pPr>
+            <a:r>
+              <a:t>FIGURA 5: MÓDULO DE CATÁLOGO INTERACTIVO CON FILTROS</a:t>
+            </a:r>
+          </a:p>
+        </p:txBody>
+      </p:sp>
       <p:pic>
         <p:nvPicPr>
-          <p:cNvPr id="8" name="Picture 7" descr="image5.png"/>
+          <p:cNvPr id="9" name="Picture 8" descr="image1.png"/>
           <p:cNvPicPr>
             <a:picLocks noChangeAspect="1"/>
           </p:cNvPicPr>
@@ -8923,8 +8907,8 @@
         </p:blipFill>
         <p:spPr>
           <a:xfrm>
-            <a:off x="6217920" y="1920240"/>
-            <a:ext cx="5029200" cy="3931920"/>
+            <a:off x="6217920" y="2194560"/>
+            <a:ext cx="5029200" cy="3657600"/>
           </a:xfrm>
           <a:prstGeom prst="rect">
             <a:avLst/>
@@ -9286,9 +9270,44 @@
           </a:p>
         </p:txBody>
       </p:sp>
+      <p:sp>
+        <p:nvSpPr>
+          <p:cNvPr id="8" name="TextBox 7"/>
+          <p:cNvSpPr txBox="1"/>
+          <p:nvPr/>
+        </p:nvSpPr>
+        <p:spPr>
+          <a:xfrm>
+            <a:off x="6217920" y="1737360"/>
+            <a:ext cx="5029200" cy="365760"/>
+          </a:xfrm>
+          <a:prstGeom prst="rect">
+            <a:avLst/>
+          </a:prstGeom>
+          <a:noFill/>
+        </p:spPr>
+        <p:txBody>
+          <a:bodyPr wrap="none">
+            <a:spAutoFit/>
+          </a:bodyPr>
+          <a:lstStyle/>
+          <a:p>
+            <a:pPr>
+              <a:defRPr sz="1100" b="1">
+                <a:solidFill>
+                  <a:srgbClr val="5B21B6"/>
+                </a:solidFill>
+              </a:defRPr>
+            </a:pPr>
+            <a:r>
+              <a:t>FIGURA 6: MÓDULO DE RESERVAS CON CALENDARIO</a:t>
+            </a:r>
+          </a:p>
+        </p:txBody>
+      </p:sp>
       <p:pic>
         <p:nvPicPr>
-          <p:cNvPr id="8" name="Picture 7" descr="image6.png"/>
+          <p:cNvPr id="9" name="Picture 8" descr="image5.png"/>
           <p:cNvPicPr>
             <a:picLocks noChangeAspect="1"/>
           </p:cNvPicPr>
@@ -9302,8 +9321,8 @@
         </p:blipFill>
         <p:spPr>
           <a:xfrm>
-            <a:off x="6217920" y="1920240"/>
-            <a:ext cx="5029200" cy="3931920"/>
+            <a:off x="6217920" y="2194560"/>
+            <a:ext cx="5029200" cy="3657600"/>
           </a:xfrm>
           <a:prstGeom prst="rect">
             <a:avLst/>
@@ -9665,9 +9684,44 @@
           </a:p>
         </p:txBody>
       </p:sp>
+      <p:sp>
+        <p:nvSpPr>
+          <p:cNvPr id="8" name="TextBox 7"/>
+          <p:cNvSpPr txBox="1"/>
+          <p:nvPr/>
+        </p:nvSpPr>
+        <p:spPr>
+          <a:xfrm>
+            <a:off x="6217920" y="1737360"/>
+            <a:ext cx="5029200" cy="365760"/>
+          </a:xfrm>
+          <a:prstGeom prst="rect">
+            <a:avLst/>
+          </a:prstGeom>
+          <a:noFill/>
+        </p:spPr>
+        <p:txBody>
+          <a:bodyPr wrap="none">
+            <a:spAutoFit/>
+          </a:bodyPr>
+          <a:lstStyle/>
+          <a:p>
+            <a:pPr>
+              <a:defRPr sz="1100" b="1">
+                <a:solidFill>
+                  <a:srgbClr val="5B21B6"/>
+                </a:solidFill>
+              </a:defRPr>
+            </a:pPr>
+            <a:r>
+              <a:t>FIGURA 7: APLICACIÓN DEL MODO ALTO CONTRASTE</a:t>
+            </a:r>
+          </a:p>
+        </p:txBody>
+      </p:sp>
       <p:pic>
         <p:nvPicPr>
-          <p:cNvPr id="8" name="Picture 7" descr="image7.png"/>
+          <p:cNvPr id="9" name="Picture 8" descr="image9.png"/>
           <p:cNvPicPr>
             <a:picLocks noChangeAspect="1"/>
           </p:cNvPicPr>
@@ -9681,8 +9735,8 @@
         </p:blipFill>
         <p:spPr>
           <a:xfrm>
-            <a:off x="6217920" y="1920240"/>
-            <a:ext cx="5029200" cy="3931920"/>
+            <a:off x="6217920" y="2194560"/>
+            <a:ext cx="5029200" cy="3657600"/>
           </a:xfrm>
           <a:prstGeom prst="rect">
             <a:avLst/>

</xml_diff>